<commit_message>
WIP Margin Metrics Example tests
</commit_message>
<xml_diff>
--- a/src/Images/2D Relations/Relation Images.pptx
+++ b/src/Images/2D Relations/Relation Images.pptx
@@ -5895,6 +5895,111 @@
               </a14:hiddenEffects>
             </a:ext>
           </a:extLst>
+        </p:spPr>
+        <p:txBody>
+          <a:bodyPr vert="horz" wrap="square" lIns="36576" tIns="36576" rIns="36576" bIns="36576" numCol="1" anchor="t" anchorCtr="0" compatLnSpc="1">
+            <a:prstTxWarp prst="textNoShape">
+              <a:avLst/>
+            </a:prstTxWarp>
+          </a:bodyPr>
+          <a:lstStyle/>
+          <a:p>
+            <a:endParaRPr lang="en-CA"/>
+          </a:p>
+        </p:txBody>
+      </p:sp>
+      <p:sp>
+        <p:nvSpPr>
+          <p:cNvPr id="22" name="Rectangle 13">
+            <a:extLst>
+              <a:ext uri="{FF2B5EF4-FFF2-40B4-BE49-F238E27FC236}">
+                <a16:creationId xmlns:a16="http://schemas.microsoft.com/office/drawing/2014/main" id="{D8A45926-72B2-F5DA-430F-07E53BFEED79}"/>
+              </a:ext>
+            </a:extLst>
+          </p:cNvPr>
+          <p:cNvSpPr>
+            <a:spLocks noChangeArrowheads="1"/>
+          </p:cNvSpPr>
+          <p:nvPr/>
+        </p:nvSpPr>
+        <p:spPr bwMode="auto">
+          <a:xfrm>
+            <a:off x="367377" y="5408313"/>
+            <a:ext cx="1828800" cy="1828800"/>
+          </a:xfrm>
+          <a:prstGeom prst="rect">
+            <a:avLst/>
+          </a:prstGeom>
+          <a:solidFill>
+            <a:srgbClr val="5B9BD5"/>
+          </a:solidFill>
+          <a:ln w="25400" algn="ctr">
+            <a:solidFill>
+              <a:srgbClr val="000000"/>
+            </a:solidFill>
+            <a:miter lim="800000"/>
+            <a:headEnd/>
+            <a:tailEnd/>
+          </a:ln>
+          <a:effectLst/>
+          <a:extLst>
+            <a:ext uri="{AF507438-7753-43E0-B8FC-AC1667EBCBE1}">
+              <a14:hiddenEffects xmlns:a14="http://schemas.microsoft.com/office/drawing/2010/main">
+                <a:effectLst>
+                  <a:outerShdw dist="35921" dir="2700000" algn="ctr" rotWithShape="0">
+                    <a:srgbClr val="000000"/>
+                  </a:outerShdw>
+                </a:effectLst>
+              </a14:hiddenEffects>
+            </a:ext>
+          </a:extLst>
+        </p:spPr>
+        <p:txBody>
+          <a:bodyPr vert="horz" wrap="square" lIns="36576" tIns="36576" rIns="36576" bIns="36576" numCol="1" anchor="t" anchorCtr="0" compatLnSpc="1">
+            <a:prstTxWarp prst="textNoShape">
+              <a:avLst/>
+            </a:prstTxWarp>
+          </a:bodyPr>
+          <a:lstStyle/>
+          <a:p>
+            <a:endParaRPr lang="en-CA"/>
+          </a:p>
+        </p:txBody>
+      </p:sp>
+      <p:sp>
+        <p:nvSpPr>
+          <p:cNvPr id="24" name="Rectangle 42">
+            <a:extLst>
+              <a:ext uri="{FF2B5EF4-FFF2-40B4-BE49-F238E27FC236}">
+                <a16:creationId xmlns:a16="http://schemas.microsoft.com/office/drawing/2014/main" id="{6E2EC480-CC68-C69A-CEB2-76E53F903C29}"/>
+              </a:ext>
+            </a:extLst>
+          </p:cNvPr>
+          <p:cNvSpPr>
+            <a:spLocks noChangeArrowheads="1"/>
+          </p:cNvSpPr>
+          <p:nvPr/>
+        </p:nvSpPr>
+        <p:spPr bwMode="auto">
+          <a:xfrm>
+            <a:off x="367376" y="5408312"/>
+            <a:ext cx="1828799" cy="1828799"/>
+          </a:xfrm>
+          <a:prstGeom prst="rect">
+            <a:avLst/>
+          </a:prstGeom>
+          <a:solidFill>
+            <a:srgbClr val="FFFF00"/>
+          </a:solidFill>
+          <a:ln w="25400" algn="ctr">
+            <a:solidFill>
+              <a:srgbClr val="000000"/>
+            </a:solidFill>
+            <a:miter lim="800000"/>
+            <a:headEnd/>
+            <a:tailEnd/>
+          </a:ln>
+          <a:effectLst/>
         </p:spPr>
         <p:txBody>
           <a:bodyPr vert="horz" wrap="square" lIns="36576" tIns="36576" rIns="36576" bIns="36576" numCol="1" anchor="t" anchorCtr="0" compatLnSpc="1">

</xml_diff>

<commit_message>
Initial notes on volume metrics
</commit_message>
<xml_diff>
--- a/src/Images/2D Relations/Relation Images.pptx
+++ b/src/Images/2D Relations/Relation Images.pptx
@@ -19,6 +19,7 @@
     <p:sldId id="265" r:id="rId16"/>
     <p:sldId id="266" r:id="rId17"/>
     <p:sldId id="267" r:id="rId18"/>
+    <p:sldId id="270" r:id="rId19"/>
   </p:sldIdLst>
   <p:sldSz cx="6858000" cy="9144000" type="letter"/>
   <p:notesSz cx="6858000" cy="9144000"/>
@@ -274,7 +275,7 @@
           <a:p>
             <a:fld id="{9C4A0F46-17CC-4DBA-8D17-CBF0F8FAF2B0}" type="datetimeFigureOut">
               <a:rPr lang="en-CA" smtClean="0"/>
-              <a:t>2026-08-20</a:t>
+              <a:t>2026-08-30</a:t>
             </a:fld>
             <a:endParaRPr lang="en-CA"/>
           </a:p>
@@ -474,7 +475,7 @@
           <a:p>
             <a:fld id="{9C4A0F46-17CC-4DBA-8D17-CBF0F8FAF2B0}" type="datetimeFigureOut">
               <a:rPr lang="en-CA" smtClean="0"/>
-              <a:t>2026-08-20</a:t>
+              <a:t>2026-08-30</a:t>
             </a:fld>
             <a:endParaRPr lang="en-CA"/>
           </a:p>
@@ -684,7 +685,7 @@
           <a:p>
             <a:fld id="{9C4A0F46-17CC-4DBA-8D17-CBF0F8FAF2B0}" type="datetimeFigureOut">
               <a:rPr lang="en-CA" smtClean="0"/>
-              <a:t>2026-08-20</a:t>
+              <a:t>2026-08-30</a:t>
             </a:fld>
             <a:endParaRPr lang="en-CA"/>
           </a:p>
@@ -884,7 +885,7 @@
           <a:p>
             <a:fld id="{9C4A0F46-17CC-4DBA-8D17-CBF0F8FAF2B0}" type="datetimeFigureOut">
               <a:rPr lang="en-CA" smtClean="0"/>
-              <a:t>2026-08-20</a:t>
+              <a:t>2026-08-30</a:t>
             </a:fld>
             <a:endParaRPr lang="en-CA"/>
           </a:p>
@@ -1160,7 +1161,7 @@
           <a:p>
             <a:fld id="{9C4A0F46-17CC-4DBA-8D17-CBF0F8FAF2B0}" type="datetimeFigureOut">
               <a:rPr lang="en-CA" smtClean="0"/>
-              <a:t>2026-08-20</a:t>
+              <a:t>2026-08-30</a:t>
             </a:fld>
             <a:endParaRPr lang="en-CA"/>
           </a:p>
@@ -1428,7 +1429,7 @@
           <a:p>
             <a:fld id="{9C4A0F46-17CC-4DBA-8D17-CBF0F8FAF2B0}" type="datetimeFigureOut">
               <a:rPr lang="en-CA" smtClean="0"/>
-              <a:t>2026-08-20</a:t>
+              <a:t>2026-08-30</a:t>
             </a:fld>
             <a:endParaRPr lang="en-CA"/>
           </a:p>
@@ -1843,7 +1844,7 @@
           <a:p>
             <a:fld id="{9C4A0F46-17CC-4DBA-8D17-CBF0F8FAF2B0}" type="datetimeFigureOut">
               <a:rPr lang="en-CA" smtClean="0"/>
-              <a:t>2026-08-20</a:t>
+              <a:t>2026-08-30</a:t>
             </a:fld>
             <a:endParaRPr lang="en-CA"/>
           </a:p>
@@ -1985,7 +1986,7 @@
           <a:p>
             <a:fld id="{9C4A0F46-17CC-4DBA-8D17-CBF0F8FAF2B0}" type="datetimeFigureOut">
               <a:rPr lang="en-CA" smtClean="0"/>
-              <a:t>2026-08-20</a:t>
+              <a:t>2026-08-30</a:t>
             </a:fld>
             <a:endParaRPr lang="en-CA"/>
           </a:p>
@@ -2098,7 +2099,7 @@
           <a:p>
             <a:fld id="{9C4A0F46-17CC-4DBA-8D17-CBF0F8FAF2B0}" type="datetimeFigureOut">
               <a:rPr lang="en-CA" smtClean="0"/>
-              <a:t>2026-08-20</a:t>
+              <a:t>2026-08-30</a:t>
             </a:fld>
             <a:endParaRPr lang="en-CA"/>
           </a:p>
@@ -2411,7 +2412,7 @@
           <a:p>
             <a:fld id="{9C4A0F46-17CC-4DBA-8D17-CBF0F8FAF2B0}" type="datetimeFigureOut">
               <a:rPr lang="en-CA" smtClean="0"/>
-              <a:t>2026-08-20</a:t>
+              <a:t>2026-08-30</a:t>
             </a:fld>
             <a:endParaRPr lang="en-CA"/>
           </a:p>
@@ -2700,7 +2701,7 @@
           <a:p>
             <a:fld id="{9C4A0F46-17CC-4DBA-8D17-CBF0F8FAF2B0}" type="datetimeFigureOut">
               <a:rPr lang="en-CA" smtClean="0"/>
-              <a:t>2026-08-20</a:t>
+              <a:t>2026-08-30</a:t>
             </a:fld>
             <a:endParaRPr lang="en-CA"/>
           </a:p>
@@ -2943,7 +2944,7 @@
           <a:p>
             <a:fld id="{9C4A0F46-17CC-4DBA-8D17-CBF0F8FAF2B0}" type="datetimeFigureOut">
               <a:rPr lang="en-CA" smtClean="0"/>
-              <a:t>2026-08-20</a:t>
+              <a:t>2026-08-30</a:t>
             </a:fld>
             <a:endParaRPr lang="en-CA"/>
           </a:p>
@@ -9693,6 +9694,562 @@
     <p:extLst>
       <p:ext uri="{BB962C8B-B14F-4D97-AF65-F5344CB8AC3E}">
         <p14:creationId xmlns:p14="http://schemas.microsoft.com/office/powerpoint/2010/main" val="2482117249"/>
+      </p:ext>
+    </p:extLst>
+  </p:cSld>
+  <p:clrMapOvr>
+    <a:masterClrMapping/>
+  </p:clrMapOvr>
+</p:sld>
+</file>
+
+<file path=ppt/slides/slide15.xml><?xml version="1.0" encoding="utf-8"?>
+<p:sld xmlns:a="http://schemas.openxmlformats.org/drawingml/2006/main" xmlns:r="http://schemas.openxmlformats.org/officeDocument/2006/relationships" xmlns:p="http://schemas.openxmlformats.org/presentationml/2006/main">
+  <p:cSld>
+    <p:spTree>
+      <p:nvGrpSpPr>
+        <p:cNvPr id="1" name=""/>
+        <p:cNvGrpSpPr/>
+        <p:nvPr/>
+      </p:nvGrpSpPr>
+      <p:grpSpPr>
+        <a:xfrm>
+          <a:off x="0" y="0"/>
+          <a:ext cx="0" cy="0"/>
+          <a:chOff x="0" y="0"/>
+          <a:chExt cx="0" cy="0"/>
+        </a:xfrm>
+      </p:grpSpPr>
+      <p:sp>
+        <p:nvSpPr>
+          <p:cNvPr id="2" name="Oval 1">
+            <a:extLst>
+              <a:ext uri="{FF2B5EF4-FFF2-40B4-BE49-F238E27FC236}">
+                <a16:creationId xmlns:a16="http://schemas.microsoft.com/office/drawing/2014/main" id="{1551D909-A69D-12F9-E0DE-567E0C367569}"/>
+              </a:ext>
+            </a:extLst>
+          </p:cNvPr>
+          <p:cNvSpPr/>
+          <p:nvPr/>
+        </p:nvSpPr>
+        <p:spPr>
+          <a:xfrm>
+            <a:off x="963168" y="1194816"/>
+            <a:ext cx="1036320" cy="1048512"/>
+          </a:xfrm>
+          <a:prstGeom prst="ellipse">
+            <a:avLst/>
+          </a:prstGeom>
+        </p:spPr>
+        <p:style>
+          <a:lnRef idx="2">
+            <a:schemeClr val="accent2">
+              <a:shade val="15000"/>
+            </a:schemeClr>
+          </a:lnRef>
+          <a:fillRef idx="1">
+            <a:schemeClr val="accent2"/>
+          </a:fillRef>
+          <a:effectRef idx="0">
+            <a:schemeClr val="accent2"/>
+          </a:effectRef>
+          <a:fontRef idx="minor">
+            <a:schemeClr val="lt1"/>
+          </a:fontRef>
+        </p:style>
+        <p:txBody>
+          <a:bodyPr rtlCol="0" anchor="ctr"/>
+          <a:lstStyle/>
+          <a:p>
+            <a:pPr algn="ctr"/>
+            <a:endParaRPr lang="en-CA"/>
+          </a:p>
+        </p:txBody>
+      </p:sp>
+      <p:sp>
+        <p:nvSpPr>
+          <p:cNvPr id="6" name="Oval 5">
+            <a:extLst>
+              <a:ext uri="{FF2B5EF4-FFF2-40B4-BE49-F238E27FC236}">
+                <a16:creationId xmlns:a16="http://schemas.microsoft.com/office/drawing/2014/main" id="{829FB1B4-648D-8FC2-2AED-D9D79B18DB07}"/>
+              </a:ext>
+            </a:extLst>
+          </p:cNvPr>
+          <p:cNvSpPr/>
+          <p:nvPr/>
+        </p:nvSpPr>
+        <p:spPr>
+          <a:xfrm>
+            <a:off x="1481328" y="1194816"/>
+            <a:ext cx="1036320" cy="1048512"/>
+          </a:xfrm>
+          <a:prstGeom prst="ellipse">
+            <a:avLst/>
+          </a:prstGeom>
+          <a:solidFill>
+            <a:schemeClr val="accent6">
+              <a:alpha val="72000"/>
+            </a:schemeClr>
+          </a:solidFill>
+        </p:spPr>
+        <p:style>
+          <a:lnRef idx="2">
+            <a:schemeClr val="accent6">
+              <a:shade val="15000"/>
+            </a:schemeClr>
+          </a:lnRef>
+          <a:fillRef idx="1">
+            <a:schemeClr val="accent6"/>
+          </a:fillRef>
+          <a:effectRef idx="0">
+            <a:schemeClr val="accent6"/>
+          </a:effectRef>
+          <a:fontRef idx="minor">
+            <a:schemeClr val="lt1"/>
+          </a:fontRef>
+        </p:style>
+        <p:txBody>
+          <a:bodyPr rtlCol="0" anchor="ctr"/>
+          <a:lstStyle/>
+          <a:p>
+            <a:pPr algn="ctr"/>
+            <a:endParaRPr lang="en-CA"/>
+          </a:p>
+        </p:txBody>
+      </p:sp>
+      <p:grpSp>
+        <p:nvGrpSpPr>
+          <p:cNvPr id="13" name="Group 12">
+            <a:extLst>
+              <a:ext uri="{FF2B5EF4-FFF2-40B4-BE49-F238E27FC236}">
+                <a16:creationId xmlns:a16="http://schemas.microsoft.com/office/drawing/2014/main" id="{D7699FBD-D7F5-EC8B-FC80-9B5E3AF6E5F3}"/>
+              </a:ext>
+            </a:extLst>
+          </p:cNvPr>
+          <p:cNvGrpSpPr/>
+          <p:nvPr/>
+        </p:nvGrpSpPr>
+        <p:grpSpPr>
+          <a:xfrm>
+            <a:off x="847344" y="2651760"/>
+            <a:ext cx="1554480" cy="1048512"/>
+            <a:chOff x="847344" y="2651760"/>
+            <a:chExt cx="1554480" cy="1048512"/>
+          </a:xfrm>
+        </p:grpSpPr>
+        <p:sp>
+          <p:nvSpPr>
+            <p:cNvPr id="8" name="Oval 7">
+              <a:extLst>
+                <a:ext uri="{FF2B5EF4-FFF2-40B4-BE49-F238E27FC236}">
+                  <a16:creationId xmlns:a16="http://schemas.microsoft.com/office/drawing/2014/main" id="{67D80C88-4385-2F5E-9FD0-8170E16FD429}"/>
+                </a:ext>
+              </a:extLst>
+            </p:cNvPr>
+            <p:cNvSpPr/>
+            <p:nvPr/>
+          </p:nvSpPr>
+          <p:spPr>
+            <a:xfrm>
+              <a:off x="847344" y="2651760"/>
+              <a:ext cx="1036320" cy="1048512"/>
+            </a:xfrm>
+            <a:prstGeom prst="ellipse">
+              <a:avLst/>
+            </a:prstGeom>
+          </p:spPr>
+          <p:style>
+            <a:lnRef idx="2">
+              <a:schemeClr val="accent2">
+                <a:shade val="15000"/>
+              </a:schemeClr>
+            </a:lnRef>
+            <a:fillRef idx="1">
+              <a:schemeClr val="accent2"/>
+            </a:fillRef>
+            <a:effectRef idx="0">
+              <a:schemeClr val="accent2"/>
+            </a:effectRef>
+            <a:fontRef idx="minor">
+              <a:schemeClr val="lt1"/>
+            </a:fontRef>
+          </p:style>
+          <p:txBody>
+            <a:bodyPr rtlCol="0" anchor="ctr"/>
+            <a:lstStyle/>
+            <a:p>
+              <a:pPr algn="ctr"/>
+              <a:endParaRPr lang="en-CA"/>
+            </a:p>
+          </p:txBody>
+        </p:sp>
+        <p:sp>
+          <p:nvSpPr>
+            <p:cNvPr id="10" name="Oval 9">
+              <a:extLst>
+                <a:ext uri="{FF2B5EF4-FFF2-40B4-BE49-F238E27FC236}">
+                  <a16:creationId xmlns:a16="http://schemas.microsoft.com/office/drawing/2014/main" id="{B6D7F30A-9F67-AF69-6F73-E7F5DDC48CE4}"/>
+                </a:ext>
+              </a:extLst>
+            </p:cNvPr>
+            <p:cNvSpPr/>
+            <p:nvPr/>
+          </p:nvSpPr>
+          <p:spPr>
+            <a:xfrm>
+              <a:off x="1365504" y="2651760"/>
+              <a:ext cx="1036320" cy="1048512"/>
+            </a:xfrm>
+            <a:prstGeom prst="ellipse">
+              <a:avLst/>
+            </a:prstGeom>
+          </p:spPr>
+          <p:style>
+            <a:lnRef idx="2">
+              <a:schemeClr val="accent2">
+                <a:shade val="15000"/>
+              </a:schemeClr>
+            </a:lnRef>
+            <a:fillRef idx="1">
+              <a:schemeClr val="accent2"/>
+            </a:fillRef>
+            <a:effectRef idx="0">
+              <a:schemeClr val="accent2"/>
+            </a:effectRef>
+            <a:fontRef idx="minor">
+              <a:schemeClr val="lt1"/>
+            </a:fontRef>
+          </p:style>
+          <p:txBody>
+            <a:bodyPr rtlCol="0" anchor="ctr"/>
+            <a:lstStyle/>
+            <a:p>
+              <a:pPr algn="ctr"/>
+              <a:endParaRPr lang="en-CA"/>
+            </a:p>
+          </p:txBody>
+        </p:sp>
+        <p:sp>
+          <p:nvSpPr>
+            <p:cNvPr id="12" name="Oval 11">
+              <a:extLst>
+                <a:ext uri="{FF2B5EF4-FFF2-40B4-BE49-F238E27FC236}">
+                  <a16:creationId xmlns:a16="http://schemas.microsoft.com/office/drawing/2014/main" id="{BCBBCF55-2DE6-4AF7-77AF-44773AAFB481}"/>
+                </a:ext>
+              </a:extLst>
+            </p:cNvPr>
+            <p:cNvSpPr/>
+            <p:nvPr/>
+          </p:nvSpPr>
+          <p:spPr>
+            <a:xfrm>
+              <a:off x="1013079" y="2720974"/>
+              <a:ext cx="1036320" cy="917575"/>
+            </a:xfrm>
+            <a:prstGeom prst="ellipse">
+              <a:avLst/>
+            </a:prstGeom>
+            <a:ln>
+              <a:noFill/>
+            </a:ln>
+          </p:spPr>
+          <p:style>
+            <a:lnRef idx="2">
+              <a:schemeClr val="accent2">
+                <a:shade val="15000"/>
+              </a:schemeClr>
+            </a:lnRef>
+            <a:fillRef idx="1">
+              <a:schemeClr val="accent2"/>
+            </a:fillRef>
+            <a:effectRef idx="0">
+              <a:schemeClr val="accent2"/>
+            </a:effectRef>
+            <a:fontRef idx="minor">
+              <a:schemeClr val="lt1"/>
+            </a:fontRef>
+          </p:style>
+          <p:txBody>
+            <a:bodyPr rtlCol="0" anchor="ctr"/>
+            <a:lstStyle/>
+            <a:p>
+              <a:pPr algn="ctr"/>
+              <a:endParaRPr lang="en-CA"/>
+            </a:p>
+          </p:txBody>
+        </p:sp>
+      </p:grpSp>
+      <p:sp>
+        <p:nvSpPr>
+          <p:cNvPr id="15" name="Oval 14">
+            <a:extLst>
+              <a:ext uri="{FF2B5EF4-FFF2-40B4-BE49-F238E27FC236}">
+                <a16:creationId xmlns:a16="http://schemas.microsoft.com/office/drawing/2014/main" id="{8FC6DF27-C0E5-E3E2-E932-F69A494B5BEC}"/>
+              </a:ext>
+            </a:extLst>
+          </p:cNvPr>
+          <p:cNvSpPr/>
+          <p:nvPr/>
+        </p:nvSpPr>
+        <p:spPr>
+          <a:xfrm>
+            <a:off x="3118104" y="1194816"/>
+            <a:ext cx="1036320" cy="1048512"/>
+          </a:xfrm>
+          <a:prstGeom prst="ellipse">
+            <a:avLst/>
+          </a:prstGeom>
+        </p:spPr>
+        <p:style>
+          <a:lnRef idx="2">
+            <a:schemeClr val="accent2">
+              <a:shade val="15000"/>
+            </a:schemeClr>
+          </a:lnRef>
+          <a:fillRef idx="1">
+            <a:schemeClr val="accent2"/>
+          </a:fillRef>
+          <a:effectRef idx="0">
+            <a:schemeClr val="accent2"/>
+          </a:effectRef>
+          <a:fontRef idx="minor">
+            <a:schemeClr val="lt1"/>
+          </a:fontRef>
+        </p:style>
+        <p:txBody>
+          <a:bodyPr rtlCol="0" anchor="ctr"/>
+          <a:lstStyle/>
+          <a:p>
+            <a:pPr algn="ctr"/>
+            <a:endParaRPr lang="en-CA"/>
+          </a:p>
+        </p:txBody>
+      </p:sp>
+      <p:sp>
+        <p:nvSpPr>
+          <p:cNvPr id="17" name="Oval 16">
+            <a:extLst>
+              <a:ext uri="{FF2B5EF4-FFF2-40B4-BE49-F238E27FC236}">
+                <a16:creationId xmlns:a16="http://schemas.microsoft.com/office/drawing/2014/main" id="{653EC10F-D309-26A5-FD1D-E32B86E2C2EF}"/>
+              </a:ext>
+            </a:extLst>
+          </p:cNvPr>
+          <p:cNvSpPr/>
+          <p:nvPr/>
+        </p:nvSpPr>
+        <p:spPr>
+          <a:xfrm>
+            <a:off x="4575048" y="1194816"/>
+            <a:ext cx="1036320" cy="1048512"/>
+          </a:xfrm>
+          <a:prstGeom prst="ellipse">
+            <a:avLst/>
+          </a:prstGeom>
+          <a:solidFill>
+            <a:schemeClr val="accent6">
+              <a:alpha val="72000"/>
+            </a:schemeClr>
+          </a:solidFill>
+        </p:spPr>
+        <p:style>
+          <a:lnRef idx="2">
+            <a:schemeClr val="accent6">
+              <a:shade val="15000"/>
+            </a:schemeClr>
+          </a:lnRef>
+          <a:fillRef idx="1">
+            <a:schemeClr val="accent6"/>
+          </a:fillRef>
+          <a:effectRef idx="0">
+            <a:schemeClr val="accent6"/>
+          </a:effectRef>
+          <a:fontRef idx="minor">
+            <a:schemeClr val="lt1"/>
+          </a:fontRef>
+        </p:style>
+        <p:txBody>
+          <a:bodyPr rtlCol="0" anchor="ctr"/>
+          <a:lstStyle/>
+          <a:p>
+            <a:pPr algn="ctr"/>
+            <a:endParaRPr lang="en-CA"/>
+          </a:p>
+        </p:txBody>
+      </p:sp>
+      <p:sp>
+        <p:nvSpPr>
+          <p:cNvPr id="21" name="Oval 20">
+            <a:extLst>
+              <a:ext uri="{FF2B5EF4-FFF2-40B4-BE49-F238E27FC236}">
+                <a16:creationId xmlns:a16="http://schemas.microsoft.com/office/drawing/2014/main" id="{05CAA0C4-165B-8807-8F25-EEF46B6B9696}"/>
+              </a:ext>
+            </a:extLst>
+          </p:cNvPr>
+          <p:cNvSpPr/>
+          <p:nvPr/>
+        </p:nvSpPr>
+        <p:spPr>
+          <a:xfrm>
+            <a:off x="847344" y="4395217"/>
+            <a:ext cx="1036320" cy="1048512"/>
+          </a:xfrm>
+          <a:prstGeom prst="ellipse">
+            <a:avLst/>
+          </a:prstGeom>
+          <a:noFill/>
+        </p:spPr>
+        <p:style>
+          <a:lnRef idx="2">
+            <a:schemeClr val="accent2">
+              <a:shade val="15000"/>
+            </a:schemeClr>
+          </a:lnRef>
+          <a:fillRef idx="1">
+            <a:schemeClr val="accent2"/>
+          </a:fillRef>
+          <a:effectRef idx="0">
+            <a:schemeClr val="accent2"/>
+          </a:effectRef>
+          <a:fontRef idx="minor">
+            <a:schemeClr val="lt1"/>
+          </a:fontRef>
+        </p:style>
+        <p:txBody>
+          <a:bodyPr rtlCol="0" anchor="ctr"/>
+          <a:lstStyle/>
+          <a:p>
+            <a:pPr algn="ctr"/>
+            <a:endParaRPr lang="en-CA"/>
+          </a:p>
+        </p:txBody>
+      </p:sp>
+      <p:sp>
+        <p:nvSpPr>
+          <p:cNvPr id="23" name="Oval 22">
+            <a:extLst>
+              <a:ext uri="{FF2B5EF4-FFF2-40B4-BE49-F238E27FC236}">
+                <a16:creationId xmlns:a16="http://schemas.microsoft.com/office/drawing/2014/main" id="{3FBBA50D-6D60-67C7-587B-BE380BD1DD8B}"/>
+              </a:ext>
+            </a:extLst>
+          </p:cNvPr>
+          <p:cNvSpPr/>
+          <p:nvPr/>
+        </p:nvSpPr>
+        <p:spPr>
+          <a:xfrm>
+            <a:off x="1365504" y="4395217"/>
+            <a:ext cx="1036320" cy="1048512"/>
+          </a:xfrm>
+          <a:prstGeom prst="ellipse">
+            <a:avLst/>
+          </a:prstGeom>
+        </p:spPr>
+        <p:style>
+          <a:lnRef idx="2">
+            <a:schemeClr val="accent2">
+              <a:shade val="15000"/>
+            </a:schemeClr>
+          </a:lnRef>
+          <a:fillRef idx="1">
+            <a:schemeClr val="accent2"/>
+          </a:fillRef>
+          <a:effectRef idx="0">
+            <a:schemeClr val="accent2"/>
+          </a:effectRef>
+          <a:fontRef idx="minor">
+            <a:schemeClr val="lt1"/>
+          </a:fontRef>
+        </p:style>
+        <p:txBody>
+          <a:bodyPr rtlCol="0" anchor="ctr"/>
+          <a:lstStyle/>
+          <a:p>
+            <a:pPr algn="ctr"/>
+            <a:endParaRPr lang="en-CA"/>
+          </a:p>
+        </p:txBody>
+      </p:sp>
+      <p:pic>
+        <p:nvPicPr>
+          <p:cNvPr id="27" name="Picture 26">
+            <a:extLst>
+              <a:ext uri="{FF2B5EF4-FFF2-40B4-BE49-F238E27FC236}">
+                <a16:creationId xmlns:a16="http://schemas.microsoft.com/office/drawing/2014/main" id="{5E78B1C2-D9D7-02B7-B2E1-11617FDF5CA1}"/>
+              </a:ext>
+            </a:extLst>
+          </p:cNvPr>
+          <p:cNvPicPr>
+            <a:picLocks noChangeAspect="1"/>
+          </p:cNvPicPr>
+          <p:nvPr/>
+        </p:nvPicPr>
+        <p:blipFill>
+          <a:blip r:embed="rId2"/>
+          <a:stretch>
+            <a:fillRect/>
+          </a:stretch>
+        </p:blipFill>
+        <p:spPr>
+          <a:xfrm>
+            <a:off x="3600547" y="4291080"/>
+            <a:ext cx="1571429" cy="1076190"/>
+          </a:xfrm>
+          <a:prstGeom prst="rect">
+            <a:avLst/>
+          </a:prstGeom>
+        </p:spPr>
+      </p:pic>
+      <p:sp>
+        <p:nvSpPr>
+          <p:cNvPr id="25" name="Oval 24">
+            <a:extLst>
+              <a:ext uri="{FF2B5EF4-FFF2-40B4-BE49-F238E27FC236}">
+                <a16:creationId xmlns:a16="http://schemas.microsoft.com/office/drawing/2014/main" id="{0C5C27A4-D97C-68E0-E47A-2D0AA7742A4B}"/>
+              </a:ext>
+            </a:extLst>
+          </p:cNvPr>
+          <p:cNvSpPr/>
+          <p:nvPr/>
+        </p:nvSpPr>
+        <p:spPr>
+          <a:xfrm>
+            <a:off x="2338959" y="3700272"/>
+            <a:ext cx="1036320" cy="1048512"/>
+          </a:xfrm>
+          <a:prstGeom prst="ellipse">
+            <a:avLst/>
+          </a:prstGeom>
+          <a:noFill/>
+        </p:spPr>
+        <p:style>
+          <a:lnRef idx="2">
+            <a:schemeClr val="accent2">
+              <a:shade val="15000"/>
+            </a:schemeClr>
+          </a:lnRef>
+          <a:fillRef idx="1">
+            <a:schemeClr val="accent2"/>
+          </a:fillRef>
+          <a:effectRef idx="0">
+            <a:schemeClr val="accent2"/>
+          </a:effectRef>
+          <a:fontRef idx="minor">
+            <a:schemeClr val="lt1"/>
+          </a:fontRef>
+        </p:style>
+        <p:txBody>
+          <a:bodyPr rtlCol="0" anchor="ctr"/>
+          <a:lstStyle/>
+          <a:p>
+            <a:pPr algn="ctr"/>
+            <a:endParaRPr lang="en-CA"/>
+          </a:p>
+        </p:txBody>
+      </p:sp>
+    </p:spTree>
+    <p:extLst>
+      <p:ext uri="{BB962C8B-B14F-4D97-AF65-F5344CB8AC3E}">
+        <p14:creationId xmlns:p14="http://schemas.microsoft.com/office/powerpoint/2010/main" val="2495630677"/>
       </p:ext>
     </p:extLst>
   </p:cSld>
@@ -25555,6 +26112,26 @@
 </file>
 
 <file path=customXml/item1.xml><?xml version="1.0" encoding="utf-8"?>
+<p:properties xmlns:p="http://schemas.microsoft.com/office/2006/metadata/properties" xmlns:xsi="http://www.w3.org/2001/XMLSchema-instance" xmlns:pc="http://schemas.microsoft.com/office/infopath/2007/PartnerControls">
+  <documentManagement>
+    <TaxCatchAll xmlns="ad65eebb-9aa8-49dc-954e-2f274fb67fdf" xsi:nil="true"/>
+    <lcf76f155ced4ddcb4097134ff3c332f xmlns="347c6671-e14e-499f-bdff-5abebf9f2841">
+      <Terms xmlns="http://schemas.microsoft.com/office/infopath/2007/PartnerControls"/>
+    </lcf76f155ced4ddcb4097134ff3c332f>
+  </documentManagement>
+</p:properties>
+</file>
+
+<file path=customXml/item2.xml><?xml version="1.0" encoding="utf-8"?>
+<?mso-contentType ?>
+<FormTemplates xmlns="http://schemas.microsoft.com/sharepoint/v3/contenttype/forms">
+  <Display>DocumentLibraryForm</Display>
+  <Edit>DocumentLibraryForm</Edit>
+  <New>DocumentLibraryForm</New>
+</FormTemplates>
+</file>
+
+<file path=customXml/item3.xml><?xml version="1.0" encoding="utf-8"?>
 <ct:contentTypeSchema xmlns:ct="http://schemas.microsoft.com/office/2006/metadata/contentType" xmlns:ma="http://schemas.microsoft.com/office/2006/metadata/properties/metaAttributes" ct:_="" ma:_="" ma:contentTypeName="Document" ma:contentTypeID="0x0101003F5ED4C9C3BCF64FB602E6BC73E05343" ma:contentTypeVersion="14" ma:contentTypeDescription="Create a new document." ma:contentTypeScope="" ma:versionID="b589f7e5eeb6bec19614f33cf7f0cf85">
   <xsd:schema xmlns:xsd="http://www.w3.org/2001/XMLSchema" xmlns:xs="http://www.w3.org/2001/XMLSchema" xmlns:p="http://schemas.microsoft.com/office/2006/metadata/properties" xmlns:ns2="347c6671-e14e-499f-bdff-5abebf9f2841" xmlns:ns3="ad65eebb-9aa8-49dc-954e-2f274fb67fdf" targetNamespace="http://schemas.microsoft.com/office/2006/metadata/properties" ma:root="true" ma:fieldsID="7942d335befb87718259710f93a11325" ns2:_="" ns3:_="">
     <xsd:import namespace="347c6671-e14e-499f-bdff-5abebf9f2841"/>
@@ -25783,27 +26360,32 @@
 </ct:contentTypeSchema>
 </file>
 
-<file path=customXml/item2.xml><?xml version="1.0" encoding="utf-8"?>
-<?mso-contentType ?>
-<FormTemplates xmlns="http://schemas.microsoft.com/sharepoint/v3/contenttype/forms">
-  <Display>DocumentLibraryForm</Display>
-  <Edit>DocumentLibraryForm</Edit>
-  <New>DocumentLibraryForm</New>
-</FormTemplates>
+<file path=customXml/itemProps1.xml><?xml version="1.0" encoding="utf-8"?>
+<ds:datastoreItem xmlns:ds="http://schemas.openxmlformats.org/officeDocument/2006/customXml" ds:itemID="{DFECE07D-CFE8-4A91-B7DC-C7679D65DB3F}">
+  <ds:schemaRefs>
+    <ds:schemaRef ds:uri="ad65eebb-9aa8-49dc-954e-2f274fb67fdf"/>
+    <ds:schemaRef ds:uri="347c6671-e14e-499f-bdff-5abebf9f2841"/>
+    <ds:schemaRef ds:uri="http://purl.org/dc/elements/1.1/"/>
+    <ds:schemaRef ds:uri="http://purl.org/dc/terms/"/>
+    <ds:schemaRef ds:uri="http://www.w3.org/XML/1998/namespace"/>
+    <ds:schemaRef ds:uri="http://schemas.microsoft.com/office/2006/documentManagement/types"/>
+    <ds:schemaRef ds:uri="http://purl.org/dc/dcmitype/"/>
+    <ds:schemaRef ds:uri="http://schemas.microsoft.com/office/infopath/2007/PartnerControls"/>
+    <ds:schemaRef ds:uri="http://schemas.openxmlformats.org/package/2006/metadata/core-properties"/>
+    <ds:schemaRef ds:uri="http://schemas.microsoft.com/office/2006/metadata/properties"/>
+  </ds:schemaRefs>
+</ds:datastoreItem>
 </file>
 
-<file path=customXml/item3.xml><?xml version="1.0" encoding="utf-8"?>
-<p:properties xmlns:p="http://schemas.microsoft.com/office/2006/metadata/properties" xmlns:xsi="http://www.w3.org/2001/XMLSchema-instance" xmlns:pc="http://schemas.microsoft.com/office/infopath/2007/PartnerControls">
-  <documentManagement>
-    <TaxCatchAll xmlns="ad65eebb-9aa8-49dc-954e-2f274fb67fdf" xsi:nil="true"/>
-    <lcf76f155ced4ddcb4097134ff3c332f xmlns="347c6671-e14e-499f-bdff-5abebf9f2841">
-      <Terms xmlns="http://schemas.microsoft.com/office/infopath/2007/PartnerControls"/>
-    </lcf76f155ced4ddcb4097134ff3c332f>
-  </documentManagement>
-</p:properties>
+<file path=customXml/itemProps2.xml><?xml version="1.0" encoding="utf-8"?>
+<ds:datastoreItem xmlns:ds="http://schemas.openxmlformats.org/officeDocument/2006/customXml" ds:itemID="{3B29D9EA-ECCE-4344-9523-DC6AE87B69AB}">
+  <ds:schemaRefs>
+    <ds:schemaRef ds:uri="http://schemas.microsoft.com/sharepoint/v3/contenttype/forms"/>
+  </ds:schemaRefs>
+</ds:datastoreItem>
 </file>
 
-<file path=customXml/itemProps1.xml><?xml version="1.0" encoding="utf-8"?>
+<file path=customXml/itemProps3.xml><?xml version="1.0" encoding="utf-8"?>
 <ds:datastoreItem xmlns:ds="http://schemas.openxmlformats.org/officeDocument/2006/customXml" ds:itemID="{E7C30B55-1DF0-4E66-9B3E-1F75FE34AF14}">
   <ds:schemaRefs>
     <ds:schemaRef ds:uri="http://schemas.microsoft.com/office/2006/metadata/contentType"/>
@@ -25820,29 +26402,4 @@
     <ds:schemaRef ds:uri="http://schemas.microsoft.com/internal/obd"/>
   </ds:schemaRefs>
 </ds:datastoreItem>
-</file>
-
-<file path=customXml/itemProps2.xml><?xml version="1.0" encoding="utf-8"?>
-<ds:datastoreItem xmlns:ds="http://schemas.openxmlformats.org/officeDocument/2006/customXml" ds:itemID="{3B29D9EA-ECCE-4344-9523-DC6AE87B69AB}">
-  <ds:schemaRefs>
-    <ds:schemaRef ds:uri="http://schemas.microsoft.com/sharepoint/v3/contenttype/forms"/>
-  </ds:schemaRefs>
-</ds:datastoreItem>
-</file>
-
-<file path=customXml/itemProps3.xml><?xml version="1.0" encoding="utf-8"?>
-<ds:datastoreItem xmlns:ds="http://schemas.openxmlformats.org/officeDocument/2006/customXml" ds:itemID="{DFECE07D-CFE8-4A91-B7DC-C7679D65DB3F}">
-  <ds:schemaRefs>
-    <ds:schemaRef ds:uri="ad65eebb-9aa8-49dc-954e-2f274fb67fdf"/>
-    <ds:schemaRef ds:uri="347c6671-e14e-499f-bdff-5abebf9f2841"/>
-    <ds:schemaRef ds:uri="http://purl.org/dc/elements/1.1/"/>
-    <ds:schemaRef ds:uri="http://purl.org/dc/terms/"/>
-    <ds:schemaRef ds:uri="http://www.w3.org/XML/1998/namespace"/>
-    <ds:schemaRef ds:uri="http://schemas.microsoft.com/office/2006/documentManagement/types"/>
-    <ds:schemaRef ds:uri="http://purl.org/dc/dcmitype/"/>
-    <ds:schemaRef ds:uri="http://schemas.microsoft.com/office/infopath/2007/PartnerControls"/>
-    <ds:schemaRef ds:uri="http://schemas.openxmlformats.org/package/2006/metadata/core-properties"/>
-    <ds:schemaRef ds:uri="http://schemas.microsoft.com/office/2006/metadata/properties"/>
-  </ds:schemaRefs>
-</ds:datastoreItem>
 </file>
</xml_diff>

<commit_message>
Add pytest configuration file and added  Images
</commit_message>
<xml_diff>
--- a/src/Images/2D Relations/Relation Images.pptx
+++ b/src/Images/2D Relations/Relation Images.pptx
@@ -9720,103 +9720,124 @@
           <a:chExt cx="0" cy="0"/>
         </a:xfrm>
       </p:grpSpPr>
-      <p:sp>
-        <p:nvSpPr>
-          <p:cNvPr id="2" name="Oval 1">
+      <p:grpSp>
+        <p:nvGrpSpPr>
+          <p:cNvPr id="4" name="Group 3">
             <a:extLst>
               <a:ext uri="{FF2B5EF4-FFF2-40B4-BE49-F238E27FC236}">
-                <a16:creationId xmlns:a16="http://schemas.microsoft.com/office/drawing/2014/main" id="{1551D909-A69D-12F9-E0DE-567E0C367569}"/>
+                <a16:creationId xmlns:a16="http://schemas.microsoft.com/office/drawing/2014/main" id="{357658CD-2876-0369-6BF6-F472B6087365}"/>
               </a:ext>
             </a:extLst>
           </p:cNvPr>
-          <p:cNvSpPr/>
+          <p:cNvGrpSpPr/>
           <p:nvPr/>
-        </p:nvSpPr>
-        <p:spPr>
+        </p:nvGrpSpPr>
+        <p:grpSpPr>
           <a:xfrm>
-            <a:off x="963168" y="1194816"/>
-            <a:ext cx="1036320" cy="1048512"/>
+            <a:off x="847344" y="1113599"/>
+            <a:ext cx="1554480" cy="1048512"/>
+            <a:chOff x="963168" y="1194816"/>
+            <a:chExt cx="1554480" cy="1048512"/>
           </a:xfrm>
-          <a:prstGeom prst="ellipse">
-            <a:avLst/>
-          </a:prstGeom>
-        </p:spPr>
-        <p:style>
-          <a:lnRef idx="2">
-            <a:schemeClr val="accent2">
-              <a:shade val="15000"/>
-            </a:schemeClr>
-          </a:lnRef>
-          <a:fillRef idx="1">
-            <a:schemeClr val="accent2"/>
-          </a:fillRef>
-          <a:effectRef idx="0">
-            <a:schemeClr val="accent2"/>
-          </a:effectRef>
-          <a:fontRef idx="minor">
-            <a:schemeClr val="lt1"/>
-          </a:fontRef>
-        </p:style>
-        <p:txBody>
-          <a:bodyPr rtlCol="0" anchor="ctr"/>
-          <a:lstStyle/>
-          <a:p>
-            <a:pPr algn="ctr"/>
-            <a:endParaRPr lang="en-CA"/>
-          </a:p>
-        </p:txBody>
-      </p:sp>
-      <p:sp>
-        <p:nvSpPr>
-          <p:cNvPr id="6" name="Oval 5">
-            <a:extLst>
-              <a:ext uri="{FF2B5EF4-FFF2-40B4-BE49-F238E27FC236}">
-                <a16:creationId xmlns:a16="http://schemas.microsoft.com/office/drawing/2014/main" id="{829FB1B4-648D-8FC2-2AED-D9D79B18DB07}"/>
-              </a:ext>
-            </a:extLst>
-          </p:cNvPr>
-          <p:cNvSpPr/>
-          <p:nvPr/>
-        </p:nvSpPr>
-        <p:spPr>
-          <a:xfrm>
-            <a:off x="1481328" y="1194816"/>
-            <a:ext cx="1036320" cy="1048512"/>
-          </a:xfrm>
-          <a:prstGeom prst="ellipse">
-            <a:avLst/>
-          </a:prstGeom>
-          <a:solidFill>
-            <a:schemeClr val="accent6">
-              <a:alpha val="72000"/>
-            </a:schemeClr>
-          </a:solidFill>
-        </p:spPr>
-        <p:style>
-          <a:lnRef idx="2">
-            <a:schemeClr val="accent6">
-              <a:shade val="15000"/>
-            </a:schemeClr>
-          </a:lnRef>
-          <a:fillRef idx="1">
-            <a:schemeClr val="accent6"/>
-          </a:fillRef>
-          <a:effectRef idx="0">
-            <a:schemeClr val="accent6"/>
-          </a:effectRef>
-          <a:fontRef idx="minor">
-            <a:schemeClr val="lt1"/>
-          </a:fontRef>
-        </p:style>
-        <p:txBody>
-          <a:bodyPr rtlCol="0" anchor="ctr"/>
-          <a:lstStyle/>
-          <a:p>
-            <a:pPr algn="ctr"/>
-            <a:endParaRPr lang="en-CA"/>
-          </a:p>
-        </p:txBody>
-      </p:sp>
+        </p:grpSpPr>
+        <p:sp>
+          <p:nvSpPr>
+            <p:cNvPr id="2" name="Oval 1">
+              <a:extLst>
+                <a:ext uri="{FF2B5EF4-FFF2-40B4-BE49-F238E27FC236}">
+                  <a16:creationId xmlns:a16="http://schemas.microsoft.com/office/drawing/2014/main" id="{1551D909-A69D-12F9-E0DE-567E0C367569}"/>
+                </a:ext>
+              </a:extLst>
+            </p:cNvPr>
+            <p:cNvSpPr/>
+            <p:nvPr/>
+          </p:nvSpPr>
+          <p:spPr>
+            <a:xfrm>
+              <a:off x="963168" y="1194816"/>
+              <a:ext cx="1036320" cy="1048512"/>
+            </a:xfrm>
+            <a:prstGeom prst="ellipse">
+              <a:avLst/>
+            </a:prstGeom>
+          </p:spPr>
+          <p:style>
+            <a:lnRef idx="2">
+              <a:schemeClr val="accent1">
+                <a:shade val="15000"/>
+              </a:schemeClr>
+            </a:lnRef>
+            <a:fillRef idx="1">
+              <a:schemeClr val="accent1"/>
+            </a:fillRef>
+            <a:effectRef idx="0">
+              <a:schemeClr val="accent1"/>
+            </a:effectRef>
+            <a:fontRef idx="minor">
+              <a:schemeClr val="lt1"/>
+            </a:fontRef>
+          </p:style>
+          <p:txBody>
+            <a:bodyPr rtlCol="0" anchor="ctr"/>
+            <a:lstStyle/>
+            <a:p>
+              <a:pPr algn="ctr"/>
+              <a:endParaRPr lang="en-CA"/>
+            </a:p>
+          </p:txBody>
+        </p:sp>
+        <p:sp>
+          <p:nvSpPr>
+            <p:cNvPr id="6" name="Oval 5">
+              <a:extLst>
+                <a:ext uri="{FF2B5EF4-FFF2-40B4-BE49-F238E27FC236}">
+                  <a16:creationId xmlns:a16="http://schemas.microsoft.com/office/drawing/2014/main" id="{829FB1B4-648D-8FC2-2AED-D9D79B18DB07}"/>
+                </a:ext>
+              </a:extLst>
+            </p:cNvPr>
+            <p:cNvSpPr/>
+            <p:nvPr/>
+          </p:nvSpPr>
+          <p:spPr>
+            <a:xfrm>
+              <a:off x="1481328" y="1194816"/>
+              <a:ext cx="1036320" cy="1048512"/>
+            </a:xfrm>
+            <a:prstGeom prst="ellipse">
+              <a:avLst/>
+            </a:prstGeom>
+            <a:solidFill>
+              <a:schemeClr val="accent6">
+                <a:alpha val="72000"/>
+              </a:schemeClr>
+            </a:solidFill>
+          </p:spPr>
+          <p:style>
+            <a:lnRef idx="2">
+              <a:schemeClr val="accent6">
+                <a:shade val="15000"/>
+              </a:schemeClr>
+            </a:lnRef>
+            <a:fillRef idx="1">
+              <a:schemeClr val="accent6"/>
+            </a:fillRef>
+            <a:effectRef idx="0">
+              <a:schemeClr val="accent6"/>
+            </a:effectRef>
+            <a:fontRef idx="minor">
+              <a:schemeClr val="lt1"/>
+            </a:fontRef>
+          </p:style>
+          <p:txBody>
+            <a:bodyPr rtlCol="0" anchor="ctr"/>
+            <a:lstStyle/>
+            <a:p>
+              <a:pPr algn="ctr"/>
+              <a:endParaRPr lang="en-CA"/>
+            </a:p>
+          </p:txBody>
+        </p:sp>
+      </p:grpSp>
       <p:grpSp>
         <p:nvGrpSpPr>
           <p:cNvPr id="13" name="Group 12">
@@ -9979,196 +10000,122 @@
           </p:txBody>
         </p:sp>
       </p:grpSp>
-      <p:sp>
-        <p:nvSpPr>
-          <p:cNvPr id="15" name="Oval 14">
+      <p:grpSp>
+        <p:nvGrpSpPr>
+          <p:cNvPr id="3" name="Group 2">
             <a:extLst>
               <a:ext uri="{FF2B5EF4-FFF2-40B4-BE49-F238E27FC236}">
-                <a16:creationId xmlns:a16="http://schemas.microsoft.com/office/drawing/2014/main" id="{8FC6DF27-C0E5-E3E2-E932-F69A494B5BEC}"/>
+                <a16:creationId xmlns:a16="http://schemas.microsoft.com/office/drawing/2014/main" id="{2EDCCD0A-6A52-7FEA-8F6F-45256C81136B}"/>
               </a:ext>
             </a:extLst>
           </p:cNvPr>
-          <p:cNvSpPr/>
+          <p:cNvGrpSpPr/>
           <p:nvPr/>
-        </p:nvSpPr>
-        <p:spPr>
+        </p:nvGrpSpPr>
+        <p:grpSpPr>
           <a:xfrm>
-            <a:off x="3118104" y="1194816"/>
-            <a:ext cx="1036320" cy="1048512"/>
+            <a:off x="2823307" y="2651760"/>
+            <a:ext cx="1554480" cy="1048512"/>
+            <a:chOff x="847344" y="4395217"/>
+            <a:chExt cx="1554480" cy="1048512"/>
           </a:xfrm>
-          <a:prstGeom prst="ellipse">
-            <a:avLst/>
-          </a:prstGeom>
-        </p:spPr>
-        <p:style>
-          <a:lnRef idx="2">
-            <a:schemeClr val="accent2">
-              <a:shade val="15000"/>
-            </a:schemeClr>
-          </a:lnRef>
-          <a:fillRef idx="1">
-            <a:schemeClr val="accent2"/>
-          </a:fillRef>
-          <a:effectRef idx="0">
-            <a:schemeClr val="accent2"/>
-          </a:effectRef>
-          <a:fontRef idx="minor">
-            <a:schemeClr val="lt1"/>
-          </a:fontRef>
-        </p:style>
-        <p:txBody>
-          <a:bodyPr rtlCol="0" anchor="ctr"/>
-          <a:lstStyle/>
-          <a:p>
-            <a:pPr algn="ctr"/>
-            <a:endParaRPr lang="en-CA"/>
-          </a:p>
-        </p:txBody>
-      </p:sp>
-      <p:sp>
-        <p:nvSpPr>
-          <p:cNvPr id="17" name="Oval 16">
-            <a:extLst>
-              <a:ext uri="{FF2B5EF4-FFF2-40B4-BE49-F238E27FC236}">
-                <a16:creationId xmlns:a16="http://schemas.microsoft.com/office/drawing/2014/main" id="{653EC10F-D309-26A5-FD1D-E32B86E2C2EF}"/>
-              </a:ext>
-            </a:extLst>
-          </p:cNvPr>
-          <p:cNvSpPr/>
-          <p:nvPr/>
-        </p:nvSpPr>
-        <p:spPr>
-          <a:xfrm>
-            <a:off x="4575048" y="1194816"/>
-            <a:ext cx="1036320" cy="1048512"/>
-          </a:xfrm>
-          <a:prstGeom prst="ellipse">
-            <a:avLst/>
-          </a:prstGeom>
-          <a:solidFill>
-            <a:schemeClr val="accent6">
-              <a:alpha val="72000"/>
-            </a:schemeClr>
-          </a:solidFill>
-        </p:spPr>
-        <p:style>
-          <a:lnRef idx="2">
-            <a:schemeClr val="accent6">
-              <a:shade val="15000"/>
-            </a:schemeClr>
-          </a:lnRef>
-          <a:fillRef idx="1">
-            <a:schemeClr val="accent6"/>
-          </a:fillRef>
-          <a:effectRef idx="0">
-            <a:schemeClr val="accent6"/>
-          </a:effectRef>
-          <a:fontRef idx="minor">
-            <a:schemeClr val="lt1"/>
-          </a:fontRef>
-        </p:style>
-        <p:txBody>
-          <a:bodyPr rtlCol="0" anchor="ctr"/>
-          <a:lstStyle/>
-          <a:p>
-            <a:pPr algn="ctr"/>
-            <a:endParaRPr lang="en-CA"/>
-          </a:p>
-        </p:txBody>
-      </p:sp>
-      <p:sp>
-        <p:nvSpPr>
-          <p:cNvPr id="21" name="Oval 20">
-            <a:extLst>
-              <a:ext uri="{FF2B5EF4-FFF2-40B4-BE49-F238E27FC236}">
-                <a16:creationId xmlns:a16="http://schemas.microsoft.com/office/drawing/2014/main" id="{05CAA0C4-165B-8807-8F25-EEF46B6B9696}"/>
-              </a:ext>
-            </a:extLst>
-          </p:cNvPr>
-          <p:cNvSpPr/>
-          <p:nvPr/>
-        </p:nvSpPr>
-        <p:spPr>
-          <a:xfrm>
-            <a:off x="847344" y="4395217"/>
-            <a:ext cx="1036320" cy="1048512"/>
-          </a:xfrm>
-          <a:prstGeom prst="ellipse">
-            <a:avLst/>
-          </a:prstGeom>
-          <a:noFill/>
-        </p:spPr>
-        <p:style>
-          <a:lnRef idx="2">
-            <a:schemeClr val="accent2">
-              <a:shade val="15000"/>
-            </a:schemeClr>
-          </a:lnRef>
-          <a:fillRef idx="1">
-            <a:schemeClr val="accent2"/>
-          </a:fillRef>
-          <a:effectRef idx="0">
-            <a:schemeClr val="accent2"/>
-          </a:effectRef>
-          <a:fontRef idx="minor">
-            <a:schemeClr val="lt1"/>
-          </a:fontRef>
-        </p:style>
-        <p:txBody>
-          <a:bodyPr rtlCol="0" anchor="ctr"/>
-          <a:lstStyle/>
-          <a:p>
-            <a:pPr algn="ctr"/>
-            <a:endParaRPr lang="en-CA"/>
-          </a:p>
-        </p:txBody>
-      </p:sp>
-      <p:sp>
-        <p:nvSpPr>
-          <p:cNvPr id="23" name="Oval 22">
-            <a:extLst>
-              <a:ext uri="{FF2B5EF4-FFF2-40B4-BE49-F238E27FC236}">
-                <a16:creationId xmlns:a16="http://schemas.microsoft.com/office/drawing/2014/main" id="{3FBBA50D-6D60-67C7-587B-BE380BD1DD8B}"/>
-              </a:ext>
-            </a:extLst>
-          </p:cNvPr>
-          <p:cNvSpPr/>
-          <p:nvPr/>
-        </p:nvSpPr>
-        <p:spPr>
-          <a:xfrm>
-            <a:off x="1365504" y="4395217"/>
-            <a:ext cx="1036320" cy="1048512"/>
-          </a:xfrm>
-          <a:prstGeom prst="ellipse">
-            <a:avLst/>
-          </a:prstGeom>
-        </p:spPr>
-        <p:style>
-          <a:lnRef idx="2">
-            <a:schemeClr val="accent2">
-              <a:shade val="15000"/>
-            </a:schemeClr>
-          </a:lnRef>
-          <a:fillRef idx="1">
-            <a:schemeClr val="accent2"/>
-          </a:fillRef>
-          <a:effectRef idx="0">
-            <a:schemeClr val="accent2"/>
-          </a:effectRef>
-          <a:fontRef idx="minor">
-            <a:schemeClr val="lt1"/>
-          </a:fontRef>
-        </p:style>
-        <p:txBody>
-          <a:bodyPr rtlCol="0" anchor="ctr"/>
-          <a:lstStyle/>
-          <a:p>
-            <a:pPr algn="ctr"/>
-            <a:endParaRPr lang="en-CA"/>
-          </a:p>
-        </p:txBody>
-      </p:sp>
+        </p:grpSpPr>
+        <p:sp>
+          <p:nvSpPr>
+            <p:cNvPr id="23" name="Oval 22">
+              <a:extLst>
+                <a:ext uri="{FF2B5EF4-FFF2-40B4-BE49-F238E27FC236}">
+                  <a16:creationId xmlns:a16="http://schemas.microsoft.com/office/drawing/2014/main" id="{3FBBA50D-6D60-67C7-587B-BE380BD1DD8B}"/>
+                </a:ext>
+              </a:extLst>
+            </p:cNvPr>
+            <p:cNvSpPr/>
+            <p:nvPr/>
+          </p:nvSpPr>
+          <p:spPr>
+            <a:xfrm>
+              <a:off x="1365504" y="4395217"/>
+              <a:ext cx="1036320" cy="1048512"/>
+            </a:xfrm>
+            <a:prstGeom prst="ellipse">
+              <a:avLst/>
+            </a:prstGeom>
+          </p:spPr>
+          <p:style>
+            <a:lnRef idx="2">
+              <a:schemeClr val="accent2">
+                <a:shade val="15000"/>
+              </a:schemeClr>
+            </a:lnRef>
+            <a:fillRef idx="1">
+              <a:schemeClr val="accent2"/>
+            </a:fillRef>
+            <a:effectRef idx="0">
+              <a:schemeClr val="accent2"/>
+            </a:effectRef>
+            <a:fontRef idx="minor">
+              <a:schemeClr val="lt1"/>
+            </a:fontRef>
+          </p:style>
+          <p:txBody>
+            <a:bodyPr rtlCol="0" anchor="ctr"/>
+            <a:lstStyle/>
+            <a:p>
+              <a:pPr algn="ctr"/>
+              <a:endParaRPr lang="en-CA"/>
+            </a:p>
+          </p:txBody>
+        </p:sp>
+        <p:sp>
+          <p:nvSpPr>
+            <p:cNvPr id="21" name="Oval 20">
+              <a:extLst>
+                <a:ext uri="{FF2B5EF4-FFF2-40B4-BE49-F238E27FC236}">
+                  <a16:creationId xmlns:a16="http://schemas.microsoft.com/office/drawing/2014/main" id="{05CAA0C4-165B-8807-8F25-EEF46B6B9696}"/>
+                </a:ext>
+              </a:extLst>
+            </p:cNvPr>
+            <p:cNvSpPr/>
+            <p:nvPr/>
+          </p:nvSpPr>
+          <p:spPr>
+            <a:xfrm>
+              <a:off x="847344" y="4395217"/>
+              <a:ext cx="1036320" cy="1048512"/>
+            </a:xfrm>
+            <a:prstGeom prst="ellipse">
+              <a:avLst/>
+            </a:prstGeom>
+            <a:solidFill>
+              <a:schemeClr val="bg1"/>
+            </a:solidFill>
+          </p:spPr>
+          <p:style>
+            <a:lnRef idx="2">
+              <a:schemeClr val="accent2">
+                <a:shade val="15000"/>
+              </a:schemeClr>
+            </a:lnRef>
+            <a:fillRef idx="1">
+              <a:schemeClr val="accent2"/>
+            </a:fillRef>
+            <a:effectRef idx="0">
+              <a:schemeClr val="accent2"/>
+            </a:effectRef>
+            <a:fontRef idx="minor">
+              <a:schemeClr val="lt1"/>
+            </a:fontRef>
+          </p:style>
+          <p:txBody>
+            <a:bodyPr rtlCol="0" anchor="ctr"/>
+            <a:lstStyle/>
+            <a:p>
+              <a:pPr algn="ctr"/>
+              <a:endParaRPr lang="en-CA"/>
+            </a:p>
+          </p:txBody>
+        </p:sp>
+      </p:grpSp>
       <p:pic>
         <p:nvPicPr>
           <p:cNvPr id="27" name="Picture 26">
@@ -10191,7 +10138,7 @@
         </p:blipFill>
         <p:spPr>
           <a:xfrm>
-            <a:off x="3600547" y="4291080"/>
+            <a:off x="2823307" y="1113599"/>
             <a:ext cx="1571429" cy="1076190"/>
           </a:xfrm>
           <a:prstGeom prst="rect">
@@ -10199,53 +10146,6 @@
           </a:prstGeom>
         </p:spPr>
       </p:pic>
-      <p:sp>
-        <p:nvSpPr>
-          <p:cNvPr id="25" name="Oval 24">
-            <a:extLst>
-              <a:ext uri="{FF2B5EF4-FFF2-40B4-BE49-F238E27FC236}">
-                <a16:creationId xmlns:a16="http://schemas.microsoft.com/office/drawing/2014/main" id="{0C5C27A4-D97C-68E0-E47A-2D0AA7742A4B}"/>
-              </a:ext>
-            </a:extLst>
-          </p:cNvPr>
-          <p:cNvSpPr/>
-          <p:nvPr/>
-        </p:nvSpPr>
-        <p:spPr>
-          <a:xfrm>
-            <a:off x="2338959" y="3700272"/>
-            <a:ext cx="1036320" cy="1048512"/>
-          </a:xfrm>
-          <a:prstGeom prst="ellipse">
-            <a:avLst/>
-          </a:prstGeom>
-          <a:noFill/>
-        </p:spPr>
-        <p:style>
-          <a:lnRef idx="2">
-            <a:schemeClr val="accent2">
-              <a:shade val="15000"/>
-            </a:schemeClr>
-          </a:lnRef>
-          <a:fillRef idx="1">
-            <a:schemeClr val="accent2"/>
-          </a:fillRef>
-          <a:effectRef idx="0">
-            <a:schemeClr val="accent2"/>
-          </a:effectRef>
-          <a:fontRef idx="minor">
-            <a:schemeClr val="lt1"/>
-          </a:fontRef>
-        </p:style>
-        <p:txBody>
-          <a:bodyPr rtlCol="0" anchor="ctr"/>
-          <a:lstStyle/>
-          <a:p>
-            <a:pPr algn="ctr"/>
-            <a:endParaRPr lang="en-CA"/>
-          </a:p>
-        </p:txBody>
-      </p:sp>
     </p:spTree>
     <p:extLst>
       <p:ext uri="{BB962C8B-B14F-4D97-AF65-F5344CB8AC3E}">
@@ -26112,26 +26012,6 @@
 </file>
 
 <file path=customXml/item1.xml><?xml version="1.0" encoding="utf-8"?>
-<p:properties xmlns:p="http://schemas.microsoft.com/office/2006/metadata/properties" xmlns:xsi="http://www.w3.org/2001/XMLSchema-instance" xmlns:pc="http://schemas.microsoft.com/office/infopath/2007/PartnerControls">
-  <documentManagement>
-    <TaxCatchAll xmlns="ad65eebb-9aa8-49dc-954e-2f274fb67fdf" xsi:nil="true"/>
-    <lcf76f155ced4ddcb4097134ff3c332f xmlns="347c6671-e14e-499f-bdff-5abebf9f2841">
-      <Terms xmlns="http://schemas.microsoft.com/office/infopath/2007/PartnerControls"/>
-    </lcf76f155ced4ddcb4097134ff3c332f>
-  </documentManagement>
-</p:properties>
-</file>
-
-<file path=customXml/item2.xml><?xml version="1.0" encoding="utf-8"?>
-<?mso-contentType ?>
-<FormTemplates xmlns="http://schemas.microsoft.com/sharepoint/v3/contenttype/forms">
-  <Display>DocumentLibraryForm</Display>
-  <Edit>DocumentLibraryForm</Edit>
-  <New>DocumentLibraryForm</New>
-</FormTemplates>
-</file>
-
-<file path=customXml/item3.xml><?xml version="1.0" encoding="utf-8"?>
 <ct:contentTypeSchema xmlns:ct="http://schemas.microsoft.com/office/2006/metadata/contentType" xmlns:ma="http://schemas.microsoft.com/office/2006/metadata/properties/metaAttributes" ct:_="" ma:_="" ma:contentTypeName="Document" ma:contentTypeID="0x0101003F5ED4C9C3BCF64FB602E6BC73E05343" ma:contentTypeVersion="14" ma:contentTypeDescription="Create a new document." ma:contentTypeScope="" ma:versionID="b589f7e5eeb6bec19614f33cf7f0cf85">
   <xsd:schema xmlns:xsd="http://www.w3.org/2001/XMLSchema" xmlns:xs="http://www.w3.org/2001/XMLSchema" xmlns:p="http://schemas.microsoft.com/office/2006/metadata/properties" xmlns:ns2="347c6671-e14e-499f-bdff-5abebf9f2841" xmlns:ns3="ad65eebb-9aa8-49dc-954e-2f274fb67fdf" targetNamespace="http://schemas.microsoft.com/office/2006/metadata/properties" ma:root="true" ma:fieldsID="7942d335befb87718259710f93a11325" ns2:_="" ns3:_="">
     <xsd:import namespace="347c6671-e14e-499f-bdff-5abebf9f2841"/>
@@ -26360,32 +26240,27 @@
 </ct:contentTypeSchema>
 </file>
 
-<file path=customXml/itemProps1.xml><?xml version="1.0" encoding="utf-8"?>
-<ds:datastoreItem xmlns:ds="http://schemas.openxmlformats.org/officeDocument/2006/customXml" ds:itemID="{DFECE07D-CFE8-4A91-B7DC-C7679D65DB3F}">
-  <ds:schemaRefs>
-    <ds:schemaRef ds:uri="ad65eebb-9aa8-49dc-954e-2f274fb67fdf"/>
-    <ds:schemaRef ds:uri="347c6671-e14e-499f-bdff-5abebf9f2841"/>
-    <ds:schemaRef ds:uri="http://purl.org/dc/elements/1.1/"/>
-    <ds:schemaRef ds:uri="http://purl.org/dc/terms/"/>
-    <ds:schemaRef ds:uri="http://www.w3.org/XML/1998/namespace"/>
-    <ds:schemaRef ds:uri="http://schemas.microsoft.com/office/2006/documentManagement/types"/>
-    <ds:schemaRef ds:uri="http://purl.org/dc/dcmitype/"/>
-    <ds:schemaRef ds:uri="http://schemas.microsoft.com/office/infopath/2007/PartnerControls"/>
-    <ds:schemaRef ds:uri="http://schemas.openxmlformats.org/package/2006/metadata/core-properties"/>
-    <ds:schemaRef ds:uri="http://schemas.microsoft.com/office/2006/metadata/properties"/>
-  </ds:schemaRefs>
-</ds:datastoreItem>
+<file path=customXml/item2.xml><?xml version="1.0" encoding="utf-8"?>
+<?mso-contentType ?>
+<FormTemplates xmlns="http://schemas.microsoft.com/sharepoint/v3/contenttype/forms">
+  <Display>DocumentLibraryForm</Display>
+  <Edit>DocumentLibraryForm</Edit>
+  <New>DocumentLibraryForm</New>
+</FormTemplates>
 </file>
 
-<file path=customXml/itemProps2.xml><?xml version="1.0" encoding="utf-8"?>
-<ds:datastoreItem xmlns:ds="http://schemas.openxmlformats.org/officeDocument/2006/customXml" ds:itemID="{3B29D9EA-ECCE-4344-9523-DC6AE87B69AB}">
-  <ds:schemaRefs>
-    <ds:schemaRef ds:uri="http://schemas.microsoft.com/sharepoint/v3/contenttype/forms"/>
-  </ds:schemaRefs>
-</ds:datastoreItem>
+<file path=customXml/item3.xml><?xml version="1.0" encoding="utf-8"?>
+<p:properties xmlns:p="http://schemas.microsoft.com/office/2006/metadata/properties" xmlns:xsi="http://www.w3.org/2001/XMLSchema-instance" xmlns:pc="http://schemas.microsoft.com/office/infopath/2007/PartnerControls">
+  <documentManagement>
+    <TaxCatchAll xmlns="ad65eebb-9aa8-49dc-954e-2f274fb67fdf" xsi:nil="true"/>
+    <lcf76f155ced4ddcb4097134ff3c332f xmlns="347c6671-e14e-499f-bdff-5abebf9f2841">
+      <Terms xmlns="http://schemas.microsoft.com/office/infopath/2007/PartnerControls"/>
+    </lcf76f155ced4ddcb4097134ff3c332f>
+  </documentManagement>
+</p:properties>
 </file>
 
-<file path=customXml/itemProps3.xml><?xml version="1.0" encoding="utf-8"?>
+<file path=customXml/itemProps1.xml><?xml version="1.0" encoding="utf-8"?>
 <ds:datastoreItem xmlns:ds="http://schemas.openxmlformats.org/officeDocument/2006/customXml" ds:itemID="{E7C30B55-1DF0-4E66-9B3E-1F75FE34AF14}">
   <ds:schemaRefs>
     <ds:schemaRef ds:uri="http://schemas.microsoft.com/office/2006/metadata/contentType"/>
@@ -26402,4 +26277,29 @@
     <ds:schemaRef ds:uri="http://schemas.microsoft.com/internal/obd"/>
   </ds:schemaRefs>
 </ds:datastoreItem>
+</file>
+
+<file path=customXml/itemProps2.xml><?xml version="1.0" encoding="utf-8"?>
+<ds:datastoreItem xmlns:ds="http://schemas.openxmlformats.org/officeDocument/2006/customXml" ds:itemID="{3B29D9EA-ECCE-4344-9523-DC6AE87B69AB}">
+  <ds:schemaRefs>
+    <ds:schemaRef ds:uri="http://schemas.microsoft.com/sharepoint/v3/contenttype/forms"/>
+  </ds:schemaRefs>
+</ds:datastoreItem>
+</file>
+
+<file path=customXml/itemProps3.xml><?xml version="1.0" encoding="utf-8"?>
+<ds:datastoreItem xmlns:ds="http://schemas.openxmlformats.org/officeDocument/2006/customXml" ds:itemID="{DFECE07D-CFE8-4A91-B7DC-C7679D65DB3F}">
+  <ds:schemaRefs>
+    <ds:schemaRef ds:uri="ad65eebb-9aa8-49dc-954e-2f274fb67fdf"/>
+    <ds:schemaRef ds:uri="347c6671-e14e-499f-bdff-5abebf9f2841"/>
+    <ds:schemaRef ds:uri="http://purl.org/dc/elements/1.1/"/>
+    <ds:schemaRef ds:uri="http://purl.org/dc/terms/"/>
+    <ds:schemaRef ds:uri="http://www.w3.org/XML/1998/namespace"/>
+    <ds:schemaRef ds:uri="http://schemas.microsoft.com/office/2006/documentManagement/types"/>
+    <ds:schemaRef ds:uri="http://purl.org/dc/dcmitype/"/>
+    <ds:schemaRef ds:uri="http://schemas.microsoft.com/office/infopath/2007/PartnerControls"/>
+    <ds:schemaRef ds:uri="http://schemas.openxmlformats.org/package/2006/metadata/core-properties"/>
+    <ds:schemaRef ds:uri="http://schemas.microsoft.com/office/2006/metadata/properties"/>
+  </ds:schemaRefs>
+</ds:datastoreItem>
 </file>
</xml_diff>